<commit_message>
style(tolet-nest): redesign visual identity with Dhaka-grounded warm charcoal/terracotta palette, Space Grotesk typography, and architectural radar
</commit_message>
<xml_diff>
--- a/Week-4-NextJS-FullStack/tolet-nest/ToLetNest_Presentation.pptx
+++ b/Week-4-NextJS-FullStack/tolet-nest/ToLetNest_Presentation.pptx
@@ -3112,11 +3112,11 @@
             <a:avLst/>
           </a:prstGeom>
           <a:solidFill>
-            <a:srgbClr val="0A0F1D"/>
+            <a:srgbClr val="14120F"/>
           </a:solidFill>
           <a:ln>
             <a:solidFill>
-              <a:srgbClr val="0A0F1D"/>
+              <a:srgbClr val="14120F"/>
             </a:solidFill>
           </a:ln>
         </p:spPr>
@@ -3167,7 +3167,7 @@
             <a:pPr>
               <a:defRPr sz="1100" b="1">
                 <a:solidFill>
-                  <a:srgbClr val="38BDF8"/>
+                  <a:srgbClr val="C9722D"/>
                 </a:solidFill>
               </a:defRPr>
             </a:pPr>
@@ -3182,7 +3182,7 @@
               </a:spcBef>
               <a:defRPr sz="2400" b="1">
                 <a:solidFill>
-                  <a:srgbClr val="F8FAFC"/>
+                  <a:srgbClr val="F6F3EE"/>
                 </a:solidFill>
               </a:defRPr>
             </a:pPr>
@@ -3197,7 +3197,7 @@
               </a:spcBef>
               <a:defRPr sz="1300">
                 <a:solidFill>
-                  <a:srgbClr val="38BDF8"/>
+                  <a:srgbClr val="C9722D"/>
                 </a:solidFill>
               </a:defRPr>
             </a:pPr>
@@ -3222,11 +3222,11 @@
             <a:avLst/>
           </a:prstGeom>
           <a:solidFill>
-            <a:srgbClr val="131C31"/>
+            <a:srgbClr val="1A1714"/>
           </a:solidFill>
           <a:ln>
             <a:solidFill>
-              <a:srgbClr val="1E293B"/>
+              <a:srgbClr val="2C2621"/>
             </a:solidFill>
           </a:ln>
         </p:spPr>
@@ -3280,7 +3280,7 @@
               </a:spcAft>
               <a:defRPr sz="1400">
                 <a:solidFill>
-                  <a:srgbClr val="F8FAFC"/>
+                  <a:srgbClr val="F6F3EE"/>
                 </a:solidFill>
               </a:defRPr>
             </a:pPr>
@@ -3295,7 +3295,7 @@
               </a:spcAft>
               <a:defRPr sz="1400">
                 <a:solidFill>
-                  <a:srgbClr val="F8FAFC"/>
+                  <a:srgbClr val="F6F3EE"/>
                 </a:solidFill>
               </a:defRPr>
             </a:pPr>
@@ -3310,7 +3310,7 @@
               </a:spcAft>
               <a:defRPr sz="1400">
                 <a:solidFill>
-                  <a:srgbClr val="F8FAFC"/>
+                  <a:srgbClr val="F6F3EE"/>
                 </a:solidFill>
               </a:defRPr>
             </a:pPr>
@@ -3325,7 +3325,7 @@
               </a:spcAft>
               <a:defRPr sz="1400">
                 <a:solidFill>
-                  <a:srgbClr val="F8FAFC"/>
+                  <a:srgbClr val="F6F3EE"/>
                 </a:solidFill>
               </a:defRPr>
             </a:pPr>
@@ -3340,7 +3340,7 @@
               </a:spcAft>
               <a:defRPr sz="1400">
                 <a:solidFill>
-                  <a:srgbClr val="F8FAFC"/>
+                  <a:srgbClr val="F6F3EE"/>
                 </a:solidFill>
               </a:defRPr>
             </a:pPr>
@@ -3383,11 +3383,11 @@
             <a:avLst/>
           </a:prstGeom>
           <a:solidFill>
-            <a:srgbClr val="0A0F1D"/>
+            <a:srgbClr val="14120F"/>
           </a:solidFill>
           <a:ln>
             <a:solidFill>
-              <a:srgbClr val="0A0F1D"/>
+              <a:srgbClr val="14120F"/>
             </a:solidFill>
           </a:ln>
         </p:spPr>
@@ -3438,7 +3438,7 @@
             <a:pPr>
               <a:defRPr sz="1100" b="1">
                 <a:solidFill>
-                  <a:srgbClr val="38BDF8"/>
+                  <a:srgbClr val="C9722D"/>
                 </a:solidFill>
               </a:defRPr>
             </a:pPr>
@@ -3453,7 +3453,7 @@
               </a:spcBef>
               <a:defRPr sz="2400" b="1">
                 <a:solidFill>
-                  <a:srgbClr val="F8FAFC"/>
+                  <a:srgbClr val="F6F3EE"/>
                 </a:solidFill>
               </a:defRPr>
             </a:pPr>
@@ -3468,7 +3468,7 @@
               </a:spcBef>
               <a:defRPr sz="1300">
                 <a:solidFill>
-                  <a:srgbClr val="38BDF8"/>
+                  <a:srgbClr val="C9722D"/>
                 </a:solidFill>
               </a:defRPr>
             </a:pPr>
@@ -3493,11 +3493,11 @@
             <a:avLst/>
           </a:prstGeom>
           <a:solidFill>
-            <a:srgbClr val="131C31"/>
+            <a:srgbClr val="1A1714"/>
           </a:solidFill>
           <a:ln>
             <a:solidFill>
-              <a:srgbClr val="1E293B"/>
+              <a:srgbClr val="2C2621"/>
             </a:solidFill>
           </a:ln>
         </p:spPr>
@@ -3551,7 +3551,7 @@
               </a:spcAft>
               <a:defRPr sz="1400">
                 <a:solidFill>
-                  <a:srgbClr val="F8FAFC"/>
+                  <a:srgbClr val="F6F3EE"/>
                 </a:solidFill>
               </a:defRPr>
             </a:pPr>
@@ -3566,7 +3566,7 @@
               </a:spcAft>
               <a:defRPr sz="1400">
                 <a:solidFill>
-                  <a:srgbClr val="F8FAFC"/>
+                  <a:srgbClr val="F6F3EE"/>
                 </a:solidFill>
               </a:defRPr>
             </a:pPr>
@@ -3581,7 +3581,7 @@
               </a:spcAft>
               <a:defRPr sz="1400">
                 <a:solidFill>
-                  <a:srgbClr val="F8FAFC"/>
+                  <a:srgbClr val="F6F3EE"/>
                 </a:solidFill>
               </a:defRPr>
             </a:pPr>
@@ -3596,7 +3596,7 @@
               </a:spcAft>
               <a:defRPr sz="1400">
                 <a:solidFill>
-                  <a:srgbClr val="F8FAFC"/>
+                  <a:srgbClr val="F6F3EE"/>
                 </a:solidFill>
               </a:defRPr>
             </a:pPr>
@@ -3639,11 +3639,11 @@
             <a:avLst/>
           </a:prstGeom>
           <a:solidFill>
-            <a:srgbClr val="0A0F1D"/>
+            <a:srgbClr val="14120F"/>
           </a:solidFill>
           <a:ln>
             <a:solidFill>
-              <a:srgbClr val="0A0F1D"/>
+              <a:srgbClr val="14120F"/>
             </a:solidFill>
           </a:ln>
         </p:spPr>
@@ -3694,7 +3694,7 @@
             <a:pPr>
               <a:defRPr sz="1100" b="1">
                 <a:solidFill>
-                  <a:srgbClr val="38BDF8"/>
+                  <a:srgbClr val="C9722D"/>
                 </a:solidFill>
               </a:defRPr>
             </a:pPr>
@@ -3709,7 +3709,7 @@
               </a:spcBef>
               <a:defRPr sz="2400" b="1">
                 <a:solidFill>
-                  <a:srgbClr val="F8FAFC"/>
+                  <a:srgbClr val="F6F3EE"/>
                 </a:solidFill>
               </a:defRPr>
             </a:pPr>
@@ -3724,7 +3724,7 @@
               </a:spcBef>
               <a:defRPr sz="1300">
                 <a:solidFill>
-                  <a:srgbClr val="38BDF8"/>
+                  <a:srgbClr val="C9722D"/>
                 </a:solidFill>
               </a:defRPr>
             </a:pPr>
@@ -3749,11 +3749,11 @@
             <a:avLst/>
           </a:prstGeom>
           <a:solidFill>
-            <a:srgbClr val="131C31"/>
+            <a:srgbClr val="1A1714"/>
           </a:solidFill>
           <a:ln>
             <a:solidFill>
-              <a:srgbClr val="1E293B"/>
+              <a:srgbClr val="2C2621"/>
             </a:solidFill>
           </a:ln>
         </p:spPr>
@@ -3807,7 +3807,7 @@
               </a:spcAft>
               <a:defRPr sz="1400">
                 <a:solidFill>
-                  <a:srgbClr val="F8FAFC"/>
+                  <a:srgbClr val="F6F3EE"/>
                 </a:solidFill>
               </a:defRPr>
             </a:pPr>
@@ -3822,7 +3822,7 @@
               </a:spcAft>
               <a:defRPr sz="1400">
                 <a:solidFill>
-                  <a:srgbClr val="F8FAFC"/>
+                  <a:srgbClr val="F6F3EE"/>
                 </a:solidFill>
               </a:defRPr>
             </a:pPr>
@@ -3837,7 +3837,7 @@
               </a:spcAft>
               <a:defRPr sz="1400">
                 <a:solidFill>
-                  <a:srgbClr val="F8FAFC"/>
+                  <a:srgbClr val="F6F3EE"/>
                 </a:solidFill>
               </a:defRPr>
             </a:pPr>
@@ -3852,7 +3852,7 @@
               </a:spcAft>
               <a:defRPr sz="1400">
                 <a:solidFill>
-                  <a:srgbClr val="F8FAFC"/>
+                  <a:srgbClr val="F6F3EE"/>
                 </a:solidFill>
               </a:defRPr>
             </a:pPr>
@@ -3895,11 +3895,11 @@
             <a:avLst/>
           </a:prstGeom>
           <a:solidFill>
-            <a:srgbClr val="0A0F1D"/>
+            <a:srgbClr val="14120F"/>
           </a:solidFill>
           <a:ln>
             <a:solidFill>
-              <a:srgbClr val="0A0F1D"/>
+              <a:srgbClr val="14120F"/>
             </a:solidFill>
           </a:ln>
         </p:spPr>
@@ -3950,7 +3950,7 @@
             <a:pPr>
               <a:defRPr sz="1100" b="1">
                 <a:solidFill>
-                  <a:srgbClr val="38BDF8"/>
+                  <a:srgbClr val="C9722D"/>
                 </a:solidFill>
               </a:defRPr>
             </a:pPr>
@@ -3965,7 +3965,7 @@
               </a:spcBef>
               <a:defRPr sz="2400" b="1">
                 <a:solidFill>
-                  <a:srgbClr val="F8FAFC"/>
+                  <a:srgbClr val="F6F3EE"/>
                 </a:solidFill>
               </a:defRPr>
             </a:pPr>
@@ -3980,7 +3980,7 @@
               </a:spcBef>
               <a:defRPr sz="1300">
                 <a:solidFill>
-                  <a:srgbClr val="38BDF8"/>
+                  <a:srgbClr val="C9722D"/>
                 </a:solidFill>
               </a:defRPr>
             </a:pPr>
@@ -4005,11 +4005,11 @@
             <a:avLst/>
           </a:prstGeom>
           <a:solidFill>
-            <a:srgbClr val="131C31"/>
+            <a:srgbClr val="1A1714"/>
           </a:solidFill>
           <a:ln>
             <a:solidFill>
-              <a:srgbClr val="1E293B"/>
+              <a:srgbClr val="2C2621"/>
             </a:solidFill>
           </a:ln>
         </p:spPr>
@@ -4063,7 +4063,7 @@
               </a:spcAft>
               <a:defRPr sz="1400">
                 <a:solidFill>
-                  <a:srgbClr val="F8FAFC"/>
+                  <a:srgbClr val="F6F3EE"/>
                 </a:solidFill>
               </a:defRPr>
             </a:pPr>
@@ -4078,7 +4078,7 @@
               </a:spcAft>
               <a:defRPr sz="1400">
                 <a:solidFill>
-                  <a:srgbClr val="F8FAFC"/>
+                  <a:srgbClr val="F6F3EE"/>
                 </a:solidFill>
               </a:defRPr>
             </a:pPr>
@@ -4093,7 +4093,7 @@
               </a:spcAft>
               <a:defRPr sz="1400">
                 <a:solidFill>
-                  <a:srgbClr val="F8FAFC"/>
+                  <a:srgbClr val="F6F3EE"/>
                 </a:solidFill>
               </a:defRPr>
             </a:pPr>
@@ -4108,7 +4108,7 @@
               </a:spcAft>
               <a:defRPr sz="1400">
                 <a:solidFill>
-                  <a:srgbClr val="F8FAFC"/>
+                  <a:srgbClr val="F6F3EE"/>
                 </a:solidFill>
               </a:defRPr>
             </a:pPr>
@@ -4151,11 +4151,11 @@
             <a:avLst/>
           </a:prstGeom>
           <a:solidFill>
-            <a:srgbClr val="0A0F1D"/>
+            <a:srgbClr val="14120F"/>
           </a:solidFill>
           <a:ln>
             <a:solidFill>
-              <a:srgbClr val="0A0F1D"/>
+              <a:srgbClr val="14120F"/>
             </a:solidFill>
           </a:ln>
         </p:spPr>
@@ -4206,7 +4206,7 @@
             <a:pPr>
               <a:defRPr sz="1100" b="1">
                 <a:solidFill>
-                  <a:srgbClr val="38BDF8"/>
+                  <a:srgbClr val="C9722D"/>
                 </a:solidFill>
               </a:defRPr>
             </a:pPr>
@@ -4221,7 +4221,7 @@
               </a:spcBef>
               <a:defRPr sz="2400" b="1">
                 <a:solidFill>
-                  <a:srgbClr val="F8FAFC"/>
+                  <a:srgbClr val="F6F3EE"/>
                 </a:solidFill>
               </a:defRPr>
             </a:pPr>
@@ -4236,7 +4236,7 @@
               </a:spcBef>
               <a:defRPr sz="1300">
                 <a:solidFill>
-                  <a:srgbClr val="38BDF8"/>
+                  <a:srgbClr val="C9722D"/>
                 </a:solidFill>
               </a:defRPr>
             </a:pPr>
@@ -4261,11 +4261,11 @@
             <a:avLst/>
           </a:prstGeom>
           <a:solidFill>
-            <a:srgbClr val="131C31"/>
+            <a:srgbClr val="1A1714"/>
           </a:solidFill>
           <a:ln>
             <a:solidFill>
-              <a:srgbClr val="1E293B"/>
+              <a:srgbClr val="2C2621"/>
             </a:solidFill>
           </a:ln>
         </p:spPr>
@@ -4319,7 +4319,7 @@
               </a:spcAft>
               <a:defRPr sz="1400">
                 <a:solidFill>
-                  <a:srgbClr val="F8FAFC"/>
+                  <a:srgbClr val="F6F3EE"/>
                 </a:solidFill>
               </a:defRPr>
             </a:pPr>
@@ -4334,7 +4334,7 @@
               </a:spcAft>
               <a:defRPr sz="1400">
                 <a:solidFill>
-                  <a:srgbClr val="F8FAFC"/>
+                  <a:srgbClr val="F6F3EE"/>
                 </a:solidFill>
               </a:defRPr>
             </a:pPr>
@@ -4349,7 +4349,7 @@
               </a:spcAft>
               <a:defRPr sz="1400">
                 <a:solidFill>
-                  <a:srgbClr val="F8FAFC"/>
+                  <a:srgbClr val="F6F3EE"/>
                 </a:solidFill>
               </a:defRPr>
             </a:pPr>
@@ -4364,7 +4364,7 @@
               </a:spcAft>
               <a:defRPr sz="1400">
                 <a:solidFill>
-                  <a:srgbClr val="F8FAFC"/>
+                  <a:srgbClr val="F6F3EE"/>
                 </a:solidFill>
               </a:defRPr>
             </a:pPr>
@@ -4407,11 +4407,11 @@
             <a:avLst/>
           </a:prstGeom>
           <a:solidFill>
-            <a:srgbClr val="0A0F1D"/>
+            <a:srgbClr val="14120F"/>
           </a:solidFill>
           <a:ln>
             <a:solidFill>
-              <a:srgbClr val="0A0F1D"/>
+              <a:srgbClr val="14120F"/>
             </a:solidFill>
           </a:ln>
         </p:spPr>
@@ -4462,7 +4462,7 @@
             <a:pPr>
               <a:defRPr sz="1100" b="1">
                 <a:solidFill>
-                  <a:srgbClr val="38BDF8"/>
+                  <a:srgbClr val="C9722D"/>
                 </a:solidFill>
               </a:defRPr>
             </a:pPr>
@@ -4477,7 +4477,7 @@
               </a:spcBef>
               <a:defRPr sz="2400" b="1">
                 <a:solidFill>
-                  <a:srgbClr val="F8FAFC"/>
+                  <a:srgbClr val="F6F3EE"/>
                 </a:solidFill>
               </a:defRPr>
             </a:pPr>
@@ -4492,7 +4492,7 @@
               </a:spcBef>
               <a:defRPr sz="1300">
                 <a:solidFill>
-                  <a:srgbClr val="38BDF8"/>
+                  <a:srgbClr val="C9722D"/>
                 </a:solidFill>
               </a:defRPr>
             </a:pPr>
@@ -4517,11 +4517,11 @@
             <a:avLst/>
           </a:prstGeom>
           <a:solidFill>
-            <a:srgbClr val="131C31"/>
+            <a:srgbClr val="1A1714"/>
           </a:solidFill>
           <a:ln>
             <a:solidFill>
-              <a:srgbClr val="1E293B"/>
+              <a:srgbClr val="2C2621"/>
             </a:solidFill>
           </a:ln>
         </p:spPr>
@@ -4575,7 +4575,7 @@
               </a:spcAft>
               <a:defRPr sz="1400">
                 <a:solidFill>
-                  <a:srgbClr val="F8FAFC"/>
+                  <a:srgbClr val="F6F3EE"/>
                 </a:solidFill>
               </a:defRPr>
             </a:pPr>
@@ -4590,7 +4590,7 @@
               </a:spcAft>
               <a:defRPr sz="1400">
                 <a:solidFill>
-                  <a:srgbClr val="F8FAFC"/>
+                  <a:srgbClr val="F6F3EE"/>
                 </a:solidFill>
               </a:defRPr>
             </a:pPr>
@@ -4605,7 +4605,7 @@
               </a:spcAft>
               <a:defRPr sz="1400">
                 <a:solidFill>
-                  <a:srgbClr val="F8FAFC"/>
+                  <a:srgbClr val="F6F3EE"/>
                 </a:solidFill>
               </a:defRPr>
             </a:pPr>
@@ -4620,7 +4620,7 @@
               </a:spcAft>
               <a:defRPr sz="1400">
                 <a:solidFill>
-                  <a:srgbClr val="F8FAFC"/>
+                  <a:srgbClr val="F6F3EE"/>
                 </a:solidFill>
               </a:defRPr>
             </a:pPr>
@@ -4663,11 +4663,11 @@
             <a:avLst/>
           </a:prstGeom>
           <a:solidFill>
-            <a:srgbClr val="0A0F1D"/>
+            <a:srgbClr val="14120F"/>
           </a:solidFill>
           <a:ln>
             <a:solidFill>
-              <a:srgbClr val="0A0F1D"/>
+              <a:srgbClr val="14120F"/>
             </a:solidFill>
           </a:ln>
         </p:spPr>
@@ -4718,7 +4718,7 @@
             <a:pPr>
               <a:defRPr sz="1100" b="1">
                 <a:solidFill>
-                  <a:srgbClr val="38BDF8"/>
+                  <a:srgbClr val="C9722D"/>
                 </a:solidFill>
               </a:defRPr>
             </a:pPr>
@@ -4733,7 +4733,7 @@
               </a:spcBef>
               <a:defRPr sz="2400" b="1">
                 <a:solidFill>
-                  <a:srgbClr val="F8FAFC"/>
+                  <a:srgbClr val="F6F3EE"/>
                 </a:solidFill>
               </a:defRPr>
             </a:pPr>
@@ -4748,7 +4748,7 @@
               </a:spcBef>
               <a:defRPr sz="1300">
                 <a:solidFill>
-                  <a:srgbClr val="38BDF8"/>
+                  <a:srgbClr val="C9722D"/>
                 </a:solidFill>
               </a:defRPr>
             </a:pPr>
@@ -4773,11 +4773,11 @@
             <a:avLst/>
           </a:prstGeom>
           <a:solidFill>
-            <a:srgbClr val="131C31"/>
+            <a:srgbClr val="1A1714"/>
           </a:solidFill>
           <a:ln>
             <a:solidFill>
-              <a:srgbClr val="1E293B"/>
+              <a:srgbClr val="2C2621"/>
             </a:solidFill>
           </a:ln>
         </p:spPr>
@@ -4831,7 +4831,7 @@
               </a:spcAft>
               <a:defRPr sz="1400">
                 <a:solidFill>
-                  <a:srgbClr val="F8FAFC"/>
+                  <a:srgbClr val="F6F3EE"/>
                 </a:solidFill>
               </a:defRPr>
             </a:pPr>
@@ -4846,7 +4846,7 @@
               </a:spcAft>
               <a:defRPr sz="1400">
                 <a:solidFill>
-                  <a:srgbClr val="F8FAFC"/>
+                  <a:srgbClr val="F6F3EE"/>
                 </a:solidFill>
               </a:defRPr>
             </a:pPr>
@@ -4861,7 +4861,7 @@
               </a:spcAft>
               <a:defRPr sz="1400">
                 <a:solidFill>
-                  <a:srgbClr val="F8FAFC"/>
+                  <a:srgbClr val="F6F3EE"/>
                 </a:solidFill>
               </a:defRPr>
             </a:pPr>
@@ -4876,7 +4876,7 @@
               </a:spcAft>
               <a:defRPr sz="1400">
                 <a:solidFill>
-                  <a:srgbClr val="F8FAFC"/>
+                  <a:srgbClr val="F6F3EE"/>
                 </a:solidFill>
               </a:defRPr>
             </a:pPr>
@@ -4919,11 +4919,11 @@
             <a:avLst/>
           </a:prstGeom>
           <a:solidFill>
-            <a:srgbClr val="0A0F1D"/>
+            <a:srgbClr val="14120F"/>
           </a:solidFill>
           <a:ln>
             <a:solidFill>
-              <a:srgbClr val="0A0F1D"/>
+              <a:srgbClr val="14120F"/>
             </a:solidFill>
           </a:ln>
         </p:spPr>
@@ -4974,7 +4974,7 @@
             <a:pPr>
               <a:defRPr sz="1100" b="1">
                 <a:solidFill>
-                  <a:srgbClr val="38BDF8"/>
+                  <a:srgbClr val="C9722D"/>
                 </a:solidFill>
               </a:defRPr>
             </a:pPr>
@@ -4989,7 +4989,7 @@
               </a:spcBef>
               <a:defRPr sz="2400" b="1">
                 <a:solidFill>
-                  <a:srgbClr val="F8FAFC"/>
+                  <a:srgbClr val="F6F3EE"/>
                 </a:solidFill>
               </a:defRPr>
             </a:pPr>
@@ -5004,7 +5004,7 @@
               </a:spcBef>
               <a:defRPr sz="1300">
                 <a:solidFill>
-                  <a:srgbClr val="38BDF8"/>
+                  <a:srgbClr val="C9722D"/>
                 </a:solidFill>
               </a:defRPr>
             </a:pPr>
@@ -5029,11 +5029,11 @@
             <a:avLst/>
           </a:prstGeom>
           <a:solidFill>
-            <a:srgbClr val="131C31"/>
+            <a:srgbClr val="1A1714"/>
           </a:solidFill>
           <a:ln>
             <a:solidFill>
-              <a:srgbClr val="1E293B"/>
+              <a:srgbClr val="2C2621"/>
             </a:solidFill>
           </a:ln>
         </p:spPr>
@@ -5087,7 +5087,7 @@
               </a:spcAft>
               <a:defRPr sz="1400">
                 <a:solidFill>
-                  <a:srgbClr val="F8FAFC"/>
+                  <a:srgbClr val="F6F3EE"/>
                 </a:solidFill>
               </a:defRPr>
             </a:pPr>
@@ -5102,7 +5102,7 @@
               </a:spcAft>
               <a:defRPr sz="1400">
                 <a:solidFill>
-                  <a:srgbClr val="F8FAFC"/>
+                  <a:srgbClr val="F6F3EE"/>
                 </a:solidFill>
               </a:defRPr>
             </a:pPr>
@@ -5117,7 +5117,7 @@
               </a:spcAft>
               <a:defRPr sz="1400">
                 <a:solidFill>
-                  <a:srgbClr val="F8FAFC"/>
+                  <a:srgbClr val="F6F3EE"/>
                 </a:solidFill>
               </a:defRPr>
             </a:pPr>
@@ -5132,7 +5132,7 @@
               </a:spcAft>
               <a:defRPr sz="1400">
                 <a:solidFill>
-                  <a:srgbClr val="F8FAFC"/>
+                  <a:srgbClr val="F6F3EE"/>
                 </a:solidFill>
               </a:defRPr>
             </a:pPr>
@@ -5175,11 +5175,11 @@
             <a:avLst/>
           </a:prstGeom>
           <a:solidFill>
-            <a:srgbClr val="0A0F1D"/>
+            <a:srgbClr val="14120F"/>
           </a:solidFill>
           <a:ln>
             <a:solidFill>
-              <a:srgbClr val="0A0F1D"/>
+              <a:srgbClr val="14120F"/>
             </a:solidFill>
           </a:ln>
         </p:spPr>
@@ -5230,7 +5230,7 @@
             <a:pPr>
               <a:defRPr sz="1100" b="1">
                 <a:solidFill>
-                  <a:srgbClr val="38BDF8"/>
+                  <a:srgbClr val="C9722D"/>
                 </a:solidFill>
               </a:defRPr>
             </a:pPr>
@@ -5245,7 +5245,7 @@
               </a:spcBef>
               <a:defRPr sz="2400" b="1">
                 <a:solidFill>
-                  <a:srgbClr val="F8FAFC"/>
+                  <a:srgbClr val="F6F3EE"/>
                 </a:solidFill>
               </a:defRPr>
             </a:pPr>
@@ -5260,7 +5260,7 @@
               </a:spcBef>
               <a:defRPr sz="1300">
                 <a:solidFill>
-                  <a:srgbClr val="38BDF8"/>
+                  <a:srgbClr val="C9722D"/>
                 </a:solidFill>
               </a:defRPr>
             </a:pPr>
@@ -5285,11 +5285,11 @@
             <a:avLst/>
           </a:prstGeom>
           <a:solidFill>
-            <a:srgbClr val="131C31"/>
+            <a:srgbClr val="1A1714"/>
           </a:solidFill>
           <a:ln>
             <a:solidFill>
-              <a:srgbClr val="1E293B"/>
+              <a:srgbClr val="2C2621"/>
             </a:solidFill>
           </a:ln>
         </p:spPr>
@@ -5343,7 +5343,7 @@
               </a:spcAft>
               <a:defRPr sz="1400">
                 <a:solidFill>
-                  <a:srgbClr val="F8FAFC"/>
+                  <a:srgbClr val="F6F3EE"/>
                 </a:solidFill>
               </a:defRPr>
             </a:pPr>
@@ -5358,7 +5358,7 @@
               </a:spcAft>
               <a:defRPr sz="1400">
                 <a:solidFill>
-                  <a:srgbClr val="F8FAFC"/>
+                  <a:srgbClr val="F6F3EE"/>
                 </a:solidFill>
               </a:defRPr>
             </a:pPr>
@@ -5373,7 +5373,7 @@
               </a:spcAft>
               <a:defRPr sz="1400">
                 <a:solidFill>
-                  <a:srgbClr val="F8FAFC"/>
+                  <a:srgbClr val="F6F3EE"/>
                 </a:solidFill>
               </a:defRPr>
             </a:pPr>
@@ -5388,7 +5388,7 @@
               </a:spcAft>
               <a:defRPr sz="1400">
                 <a:solidFill>
-                  <a:srgbClr val="F8FAFC"/>
+                  <a:srgbClr val="F6F3EE"/>
                 </a:solidFill>
               </a:defRPr>
             </a:pPr>
@@ -5431,11 +5431,11 @@
             <a:avLst/>
           </a:prstGeom>
           <a:solidFill>
-            <a:srgbClr val="0A0F1D"/>
+            <a:srgbClr val="14120F"/>
           </a:solidFill>
           <a:ln>
             <a:solidFill>
-              <a:srgbClr val="0A0F1D"/>
+              <a:srgbClr val="14120F"/>
             </a:solidFill>
           </a:ln>
         </p:spPr>
@@ -5486,7 +5486,7 @@
             <a:pPr>
               <a:defRPr sz="1100" b="1">
                 <a:solidFill>
-                  <a:srgbClr val="38BDF8"/>
+                  <a:srgbClr val="C9722D"/>
                 </a:solidFill>
               </a:defRPr>
             </a:pPr>
@@ -5501,7 +5501,7 @@
               </a:spcBef>
               <a:defRPr sz="2400" b="1">
                 <a:solidFill>
-                  <a:srgbClr val="F8FAFC"/>
+                  <a:srgbClr val="F6F3EE"/>
                 </a:solidFill>
               </a:defRPr>
             </a:pPr>
@@ -5516,7 +5516,7 @@
               </a:spcBef>
               <a:defRPr sz="1300">
                 <a:solidFill>
-                  <a:srgbClr val="38BDF8"/>
+                  <a:srgbClr val="C9722D"/>
                 </a:solidFill>
               </a:defRPr>
             </a:pPr>
@@ -5541,11 +5541,11 @@
             <a:avLst/>
           </a:prstGeom>
           <a:solidFill>
-            <a:srgbClr val="131C31"/>
+            <a:srgbClr val="1A1714"/>
           </a:solidFill>
           <a:ln>
             <a:solidFill>
-              <a:srgbClr val="1E293B"/>
+              <a:srgbClr val="2C2621"/>
             </a:solidFill>
           </a:ln>
         </p:spPr>
@@ -5599,7 +5599,7 @@
               </a:spcAft>
               <a:defRPr sz="1400">
                 <a:solidFill>
-                  <a:srgbClr val="F8FAFC"/>
+                  <a:srgbClr val="F6F3EE"/>
                 </a:solidFill>
               </a:defRPr>
             </a:pPr>
@@ -5614,7 +5614,7 @@
               </a:spcAft>
               <a:defRPr sz="1400">
                 <a:solidFill>
-                  <a:srgbClr val="F8FAFC"/>
+                  <a:srgbClr val="F6F3EE"/>
                 </a:solidFill>
               </a:defRPr>
             </a:pPr>
@@ -5629,7 +5629,7 @@
               </a:spcAft>
               <a:defRPr sz="1400">
                 <a:solidFill>
-                  <a:srgbClr val="F8FAFC"/>
+                  <a:srgbClr val="F6F3EE"/>
                 </a:solidFill>
               </a:defRPr>
             </a:pPr>

</xml_diff>